<commit_message>
Remove em dashes from the onboarding deck and handbook
Rewrote every em-dash-joined clause in both documents (EN + ES) using
commas, colons, semicolons, periods, or parentheses depending on
context. Contact-detail separators switched to middle dots. The
bullet-point glyph in the deck also moved off the em-dash character.
</commit_message>
<xml_diff>
--- a/zebraish-christian-onboarding-en.pptx
+++ b/zebraish-christian-onboarding-en.pptx
@@ -3267,7 +3267,7 @@
                 </a:solidFill>
                 <a:latin typeface="Helvetica Neue"/>
               </a:rPr>
-              <a:t>Everything you need to know about the brand, your role, and how the collaboration works day to day — before you sign anything.</a:t>
+              <a:t>Everything you need to know about the brand, your role, and how the collaboration works day to day, before you sign anything.</a:t>
             </a:r>
           </a:p>
         </p:txBody>
@@ -3536,7 +3536,7 @@
                 </a:solidFill>
                 <a:latin typeface="Helvetica Neue"/>
               </a:rPr>
-              <a:t>Onboarding presentation — companion to the Official Collaboration Agreement</a:t>
+              <a:t>Onboarding presentation, companion to the Official Collaboration Agreement</a:t>
             </a:r>
           </a:p>
         </p:txBody>
@@ -3640,7 +3640,7 @@
                 </a:solidFill>
                 <a:latin typeface="Helvetica Neue"/>
               </a:rPr>
-              <a:t>Client introductions — no referral code needed</a:t>
+              <a:t>Client introductions: no referral code needed</a:t>
             </a:r>
           </a:p>
         </p:txBody>
@@ -3717,7 +3717,7 @@
                 </a:solidFill>
                 <a:latin typeface="Helvetica Neue"/>
               </a:rPr>
-              <a:t>—  </a:t>
+              <a:t>•  </a:t>
             </a:r>
             <a:r>
               <a:rPr sz="1550">
@@ -3726,7 +3726,7 @@
                 </a:solidFill>
                 <a:latin typeface="Helvetica Neue"/>
               </a:rPr>
-              <a:t>When you introduce a client, the project gets opened through the Zebraish Project &amp; Payment Portal (or you just tell Joshua directly and he opens it) — it gets a unique Project ID, like ZB-00017.</a:t>
+              <a:t>When you introduce a client, the project gets opened through the Zebraish Project &amp; Payment Portal (or you just tell Joshua directly and he opens it), and it gets a unique Project ID, like ZB-00017.</a:t>
             </a:r>
           </a:p>
           <a:p>
@@ -3745,7 +3745,7 @@
                 </a:solidFill>
                 <a:latin typeface="Helvetica Neue"/>
               </a:rPr>
-              <a:t>—  </a:t>
+              <a:t>•  </a:t>
             </a:r>
             <a:r>
               <a:rPr sz="1550">
@@ -3773,7 +3773,7 @@
                 </a:solidFill>
                 <a:latin typeface="Helvetica Neue"/>
               </a:rPr>
-              <a:t>—  </a:t>
+              <a:t>•  </a:t>
             </a:r>
             <a:r>
               <a:rPr sz="1550">
@@ -3782,7 +3782,7 @@
                 </a:solidFill>
                 <a:latin typeface="Helvetica Neue"/>
               </a:rPr>
-              <a:t>Commission isn't calculated by matching individual clients to you — it's based on all qualifying Zebraish payments received during your Term.</a:t>
+              <a:t>Commission isn't calculated by matching individual clients to you: it's based on all qualifying Zebraish payments received during your Term.</a:t>
             </a:r>
           </a:p>
         </p:txBody>
@@ -4292,7 +4292,7 @@
                 </a:solidFill>
                 <a:latin typeface="Helvetica Neue"/>
               </a:rPr>
-              <a:t>payout day — reviewed and sent by bank transfer</a:t>
+              <a:t>payout day, reviewed and sent by bank transfer</a:t>
             </a:r>
           </a:p>
         </p:txBody>
@@ -4375,7 +4375,7 @@
                 </a:solidFill>
                 <a:latin typeface="Helvetica Neue"/>
               </a:rPr>
-              <a:t>No arbitrary cap on what you can earn, and no fixed salary — compensation is commission-based for the Initial Term.</a:t>
+              <a:t>No arbitrary cap on what you can earn, and no fixed salary: compensation is commission-based for the Initial Term.</a:t>
             </a:r>
           </a:p>
         </p:txBody>
@@ -4616,7 +4616,7 @@
                 </a:solidFill>
                 <a:latin typeface="Helvetica Neue"/>
               </a:rPr>
-              <a:t>Weekly payout — how it works</a:t>
+              <a:t>Weekly payout: how it works</a:t>
             </a:r>
           </a:p>
         </p:txBody>
@@ -5736,7 +5736,7 @@
                 </a:solidFill>
                 <a:latin typeface="Helvetica Neue"/>
               </a:rPr>
-              <a:t>—  </a:t>
+              <a:t>•  </a:t>
             </a:r>
             <a:r>
               <a:rPr sz="1550">
@@ -5745,7 +5745,7 @@
                 </a:solidFill>
                 <a:latin typeface="Helvetica Neue"/>
               </a:rPr>
-              <a:t>A private view of your weekly commission — Project IDs, amounts, and PAID / PENDING status.</a:t>
+              <a:t>A private view of your weekly commission: Project IDs, amounts, and PAID / PENDING status.</a:t>
             </a:r>
           </a:p>
           <a:p>
@@ -5764,7 +5764,7 @@
                 </a:solidFill>
                 <a:latin typeface="Helvetica Neue"/>
               </a:rPr>
-              <a:t>—  </a:t>
+              <a:t>•  </a:t>
             </a:r>
             <a:r>
               <a:rPr sz="1550">
@@ -5792,7 +5792,7 @@
                 </a:solidFill>
                 <a:latin typeface="Helvetica Neue"/>
               </a:rPr>
-              <a:t>—  </a:t>
+              <a:t>•  </a:t>
             </a:r>
             <a:r>
               <a:rPr sz="1550">
@@ -5801,7 +5801,7 @@
                 </a:solidFill>
                 <a:latin typeface="Helvetica Neue"/>
               </a:rPr>
-              <a:t>This is being built alongside the Project Portal — Joshua will confirm once it's live; a written weekly summary works as a bridge until then.</a:t>
+              <a:t>This is being built alongside the Project Portal. Joshua will confirm once it's live; a written weekly summary works as a bridge until then.</a:t>
             </a:r>
           </a:p>
         </p:txBody>
@@ -6482,7 +6482,7 @@
                 </a:solidFill>
                 <a:latin typeface="Helvetica Neue"/>
               </a:rPr>
-              <a:t>—  </a:t>
+              <a:t>•  </a:t>
             </a:r>
             <a:r>
               <a:rPr sz="1550">
@@ -6510,7 +6510,7 @@
                 </a:solidFill>
                 <a:latin typeface="Helvetica Neue"/>
               </a:rPr>
-              <a:t>—  </a:t>
+              <a:t>•  </a:t>
             </a:r>
             <a:r>
               <a:rPr sz="1550">
@@ -6538,7 +6538,7 @@
                 </a:solidFill>
                 <a:latin typeface="Helvetica Neue"/>
               </a:rPr>
-              <a:t>—  </a:t>
+              <a:t>•  </a:t>
             </a:r>
             <a:r>
               <a:rPr sz="1550">
@@ -6566,7 +6566,7 @@
                 </a:solidFill>
                 <a:latin typeface="Helvetica Neue"/>
               </a:rPr>
-              <a:t>—  </a:t>
+              <a:t>•  </a:t>
             </a:r>
             <a:r>
               <a:rPr sz="1550">
@@ -6594,7 +6594,7 @@
                 </a:solidFill>
                 <a:latin typeface="Helvetica Neue"/>
               </a:rPr>
-              <a:t>—  </a:t>
+              <a:t>•  </a:t>
             </a:r>
             <a:r>
               <a:rPr sz="1550">
@@ -6921,7 +6921,7 @@
                 </a:solidFill>
                 <a:latin typeface="Helvetica Neue"/>
               </a:rPr>
-              <a:t>—  </a:t>
+              <a:t>•  </a:t>
             </a:r>
             <a:r>
               <a:rPr sz="1550">
@@ -6930,7 +6930,7 @@
                 </a:solidFill>
                 <a:latin typeface="Helvetica Neue"/>
               </a:rPr>
-              <a:t>You keep full ownership of your identity, image, and likeness — always.</a:t>
+              <a:t>You keep full ownership of your identity, image, and likeness, always.</a:t>
             </a:r>
           </a:p>
           <a:p>
@@ -6949,7 +6949,7 @@
                 </a:solidFill>
                 <a:latin typeface="Helvetica Neue"/>
               </a:rPr>
-              <a:t>—  </a:t>
+              <a:t>•  </a:t>
             </a:r>
             <a:r>
               <a:rPr sz="1550">
@@ -6977,7 +6977,7 @@
                 </a:solidFill>
                 <a:latin typeface="Helvetica Neue"/>
               </a:rPr>
-              <a:t>—  </a:t>
+              <a:t>•  </a:t>
             </a:r>
             <a:r>
               <a:rPr sz="1550">
@@ -6986,7 +6986,7 @@
                 </a:solidFill>
                 <a:latin typeface="Helvetica Neue"/>
               </a:rPr>
-              <a:t>That license runs during the Term, plus 6 months after it ends — for archival and portfolio use only, not new campaigns.</a:t>
+              <a:t>That license runs during the Term, plus 6 months after it ends, for archival and portfolio use only, not new campaigns.</a:t>
             </a:r>
           </a:p>
           <a:p>
@@ -7005,7 +7005,7 @@
                 </a:solidFill>
                 <a:latin typeface="Helvetica Neue"/>
               </a:rPr>
-              <a:t>—  </a:t>
+              <a:t>•  </a:t>
             </a:r>
             <a:r>
               <a:rPr sz="1550">
@@ -7014,7 +7014,7 @@
                 </a:solidFill>
                 <a:latin typeface="Helvetica Neue"/>
               </a:rPr>
-              <a:t>Confidential Zebraish information (products, pricing, strategy) stays confidential — during and after the Term.</a:t>
+              <a:t>Confidential Zebraish information (products, pricing, strategy) stays confidential, during and after the Term.</a:t>
             </a:r>
           </a:p>
         </p:txBody>
@@ -7656,7 +7656,7 @@
                 </a:solidFill>
                 <a:latin typeface="Helvetica Neue"/>
               </a:rPr>
-              <a:t>Only by mutual written agreement — otherwise it ends automatically</a:t>
+              <a:t>Only by mutual written agreement; otherwise it ends automatically</a:t>
             </a:r>
           </a:p>
         </p:txBody>
@@ -8375,7 +8375,7 @@
                 </a:solidFill>
                 <a:latin typeface="Helvetica Neue"/>
               </a:rPr>
-              <a:t>—  </a:t>
+              <a:t>•  </a:t>
             </a:r>
             <a:r>
               <a:rPr sz="1550">
@@ -8384,7 +8384,7 @@
                 </a:solidFill>
                 <a:latin typeface="Helvetica Neue"/>
               </a:rPr>
-              <a:t>If paid ads or boosted posts make sense, Joshua funds and confirms the budget in writing before anything's spent — you never commit Zebraish's money without sign-off.</a:t>
+              <a:t>If paid ads or boosted posts make sense, Joshua funds and confirms the budget in writing before anything's spent. You never commit Zebraish's money without sign-off.</a:t>
             </a:r>
           </a:p>
           <a:p>
@@ -8403,7 +8403,7 @@
                 </a:solidFill>
                 <a:latin typeface="Helvetica Neue"/>
               </a:rPr>
-              <a:t>—  </a:t>
+              <a:t>•  </a:t>
             </a:r>
             <a:r>
               <a:rPr sz="1550">
@@ -8431,7 +8431,7 @@
                 </a:solidFill>
                 <a:latin typeface="Helvetica Neue"/>
               </a:rPr>
-              <a:t>—  </a:t>
+              <a:t>•  </a:t>
             </a:r>
             <a:r>
               <a:rPr sz="1550">
@@ -8440,7 +8440,7 @@
                 </a:solidFill>
                 <a:latin typeface="Helvetica Neue"/>
               </a:rPr>
-              <a:t>Informal, low-friction — a call or a message is enough. It keeps both sides aligned without needing to touch the Agreement itself.</a:t>
+              <a:t>Informal, low-friction: a call or a message is enough. It keeps both sides aligned without needing to touch the Agreement itself.</a:t>
             </a:r>
           </a:p>
         </p:txBody>
@@ -8792,7 +8792,7 @@
                 </a:solidFill>
                 <a:latin typeface="Helvetica Neue"/>
               </a:rPr>
-              <a:t>A preview, not the current job — reference styling for the Fashion line, launching soon. Animal-inspired patterns and textures reinterpreted for a premium range. Your role expands to include this once it's live; for now, the focus is Zebraish Studio.</a:t>
+              <a:t>A preview, not the current job: reference styling for the Fashion line, launching soon. Animal-inspired patterns and textures reinterpreted for a premium range. Your role expands to include this once it's live; for now, the focus is Zebraish Studio.</a:t>
             </a:r>
           </a:p>
         </p:txBody>
@@ -9459,7 +9459,7 @@
                 </a:solidFill>
                 <a:latin typeface="Helvetica Neue"/>
               </a:rPr>
-              <a:t>This presentation is context. The Official Collaboration Agreement is the document that makes it binding — read it, ask anything, and sign when you're ready.</a:t>
+              <a:t>This presentation is context. The Official Collaboration Agreement is the document that makes it binding. Read it, ask anything, and sign when you're ready.</a:t>
             </a:r>
           </a:p>
         </p:txBody>
@@ -9537,7 +9537,7 @@
                 </a:solidFill>
                 <a:latin typeface="Helvetica Neue"/>
               </a:rPr>
-              <a:t>Joshua Bankole — j0shbankole19@gmail.com — +234 816 532 0780</a:t>
+              <a:t>Joshua Bankole · j0shbankole19@gmail.com · +234 816 532 0780</a:t>
             </a:r>
           </a:p>
         </p:txBody>
@@ -9615,7 +9615,7 @@
                 </a:solidFill>
                 <a:latin typeface="Helvetica Neue"/>
               </a:rPr>
-              <a:t>Christian Prieto — +34 631 53 71 36 — Barcelona, Spain</a:t>
+              <a:t>Christian Prieto · +34 631 53 71 36 · Barcelona, Spain</a:t>
             </a:r>
           </a:p>
         </p:txBody>
@@ -10011,7 +10011,7 @@
                 </a:solidFill>
                 <a:latin typeface="Helvetica Neue"/>
               </a:rPr>
-              <a:t>—  </a:t>
+              <a:t>•  </a:t>
             </a:r>
             <a:r>
               <a:rPr sz="1550">
@@ -10039,7 +10039,7 @@
                 </a:solidFill>
                 <a:latin typeface="Helvetica Neue"/>
               </a:rPr>
-              <a:t>—  </a:t>
+              <a:t>•  </a:t>
             </a:r>
             <a:r>
               <a:rPr sz="1550">
@@ -10048,7 +10048,7 @@
                 </a:solidFill>
                 <a:latin typeface="Helvetica Neue"/>
               </a:rPr>
-              <a:t>Studio and The Board are where the tech and product work happens — building, prototyping, and shipping ideas. This is what's live right now, and it's what Zebraish is launching with.</a:t>
+              <a:t>Studio and The Board are where the tech and product work happens: building, prototyping, and shipping ideas. This is what's live right now, and it's what Zebraish is launching with.</a:t>
             </a:r>
           </a:p>
           <a:p>
@@ -10067,7 +10067,7 @@
                 </a:solidFill>
                 <a:latin typeface="Helvetica Neue"/>
               </a:rPr>
-              <a:t>—  </a:t>
+              <a:t>•  </a:t>
             </a:r>
             <a:r>
               <a:rPr sz="1550">
@@ -10076,7 +10076,7 @@
                 </a:solidFill>
                 <a:latin typeface="Helvetica Neue"/>
               </a:rPr>
-              <a:t>Fashion is the creative expression of the same brand — apparel and style built around a distinct, animal-inspired aesthetic. It's coming soon, but the product line isn't public yet.</a:t>
+              <a:t>Fashion is the creative expression of the same brand: apparel and style built around a distinct, animal-inspired aesthetic. It's coming soon, but the product line isn't public yet.</a:t>
             </a:r>
           </a:p>
           <a:p>
@@ -10095,7 +10095,7 @@
                 </a:solidFill>
                 <a:latin typeface="Helvetica Neue"/>
               </a:rPr>
-              <a:t>—  </a:t>
+              <a:t>•  </a:t>
             </a:r>
             <a:r>
               <a:rPr sz="1550">
@@ -10422,7 +10422,7 @@
                 </a:solidFill>
                 <a:latin typeface="Helvetica Neue"/>
               </a:rPr>
-              <a:t>—  </a:t>
+              <a:t>•  </a:t>
             </a:r>
             <a:r>
               <a:rPr sz="1550">
@@ -10431,7 +10431,7 @@
                 </a:solidFill>
                 <a:latin typeface="Helvetica Neue"/>
               </a:rPr>
-              <a:t>You're joining as Zebraish's Official Collaboration Partner — and right now, your job is Studio: representing it, building awareness for it, and actively bringing in customers for it, because that's what Zebraish is starting with.</a:t>
+              <a:t>You're joining as Zebraish's Official Collaboration Partner, and right now, your job is Studio: representing it, building awareness for it, and actively bringing in customers for it, because that's what Zebraish is starting with.</a:t>
             </a:r>
           </a:p>
           <a:p>
@@ -10450,7 +10450,7 @@
                 </a:solidFill>
                 <a:latin typeface="Helvetica Neue"/>
               </a:rPr>
-              <a:t>—  </a:t>
+              <a:t>•  </a:t>
             </a:r>
             <a:r>
               <a:rPr sz="1550">
@@ -10459,7 +10459,7 @@
                 </a:solidFill>
                 <a:latin typeface="Helvetica Neue"/>
               </a:rPr>
-              <a:t>You don't need to be a tech person to do this well. Your audience trusts you — that's the asset. Point people toward Zebraish Studio, explain what it does in plain terms, and make the introduction.</a:t>
+              <a:t>You don't need to be a tech person to do this well. Your audience trusts you. That's the asset. Point people toward Zebraish Studio, explain what it does in plain terms, and make the introduction.</a:t>
             </a:r>
           </a:p>
           <a:p>
@@ -10478,7 +10478,7 @@
                 </a:solidFill>
                 <a:latin typeface="Helvetica Neue"/>
               </a:rPr>
-              <a:t>—  </a:t>
+              <a:t>•  </a:t>
             </a:r>
             <a:r>
               <a:rPr sz="1550">
@@ -10487,7 +10487,7 @@
                 </a:solidFill>
                 <a:latin typeface="Helvetica Neue"/>
               </a:rPr>
-              <a:t>Fashion joins your role once the clothing line actually launches, which is coming soon. When it does, it'll likely be an even more natural fit for you — but the work starts with Studio.</a:t>
+              <a:t>Fashion joins your role once the clothing line actually launches, which is coming soon. When it does, it'll likely be an even more natural fit for you, but the work starts with Studio.</a:t>
             </a:r>
           </a:p>
         </p:txBody>
@@ -11168,7 +11168,7 @@
                 </a:solidFill>
                 <a:latin typeface="Helvetica Neue"/>
               </a:rPr>
-              <a:t>—  </a:t>
+              <a:t>•  </a:t>
             </a:r>
             <a:r>
               <a:rPr sz="1550">
@@ -11196,7 +11196,7 @@
                 </a:solidFill>
                 <a:latin typeface="Helvetica Neue"/>
               </a:rPr>
-              <a:t>—  </a:t>
+              <a:t>•  </a:t>
             </a:r>
             <a:r>
               <a:rPr sz="1550">
@@ -11205,7 +11205,7 @@
                 </a:solidFill>
                 <a:latin typeface="Helvetica Neue"/>
               </a:rPr>
-              <a:t>Current focus: promoting Zebraish Studio and bringing in customers for it — that's the priority for the length of this Term.</a:t>
+              <a:t>Current focus: promoting Zebraish Studio and bringing in customers for it. That's the priority for the length of this Term.</a:t>
             </a:r>
           </a:p>
           <a:p>
@@ -11224,7 +11224,7 @@
                 </a:solidFill>
                 <a:latin typeface="Helvetica Neue"/>
               </a:rPr>
-              <a:t>—  </a:t>
+              <a:t>•  </a:t>
             </a:r>
             <a:r>
               <a:rPr sz="1550">
@@ -11233,7 +11233,7 @@
                 </a:solidFill>
                 <a:latin typeface="Helvetica Neue"/>
               </a:rPr>
-              <a:t>Non-exclusive — you're free to work with, promote, or represent other brands during the Term, as long as it doesn't conflict with your Zebraish obligations.</a:t>
+              <a:t>Non-exclusive: you're free to work with, promote, or represent other brands during the Term, as long as it doesn't conflict with your Zebraish obligations.</a:t>
             </a:r>
           </a:p>
           <a:p>
@@ -11252,7 +11252,7 @@
                 </a:solidFill>
                 <a:latin typeface="Helvetica Neue"/>
               </a:rPr>
-              <a:t>—  </a:t>
+              <a:t>•  </a:t>
             </a:r>
             <a:r>
               <a:rPr sz="1550">
@@ -11280,7 +11280,7 @@
                 </a:solidFill>
                 <a:latin typeface="Helvetica Neue"/>
               </a:rPr>
-              <a:t>—  </a:t>
+              <a:t>•  </a:t>
             </a:r>
             <a:r>
               <a:rPr sz="1550">
@@ -11289,7 +11289,7 @@
                 </a:solidFill>
                 <a:latin typeface="Helvetica Neue"/>
               </a:rPr>
-              <a:t>You represent Zebraish, build brand awareness, create content, and introduce potential clients — all detailed in the Agreement itself.</a:t>
+              <a:t>You represent Zebraish, build brand awareness, create content, and introduce potential clients, all detailed in the Agreement itself.</a:t>
             </a:r>
           </a:p>
         </p:txBody>
@@ -11607,7 +11607,7 @@
                 </a:solidFill>
                 <a:latin typeface="Helvetica Neue"/>
               </a:rPr>
-              <a:t>—  </a:t>
+              <a:t>•  </a:t>
             </a:r>
             <a:r>
               <a:rPr sz="1550">
@@ -11616,7 +11616,7 @@
                 </a:solidFill>
                 <a:latin typeface="Helvetica Neue"/>
               </a:rPr>
-              <a:t>Proactively identify and approach potential Zebraish Studio clients within your own network and audience — anyone who could use what Studio builds — through DMs, in-person introductions, social engagement, whatever fits.</a:t>
+              <a:t>Proactively identify and approach potential Zebraish Studio clients within your own network and audience (anyone who could use what Studio builds) through DMs, in-person introductions, social engagement, whatever fits.</a:t>
             </a:r>
           </a:p>
           <a:p>
@@ -11635,7 +11635,7 @@
                 </a:solidFill>
                 <a:latin typeface="Helvetica Neue"/>
               </a:rPr>
-              <a:t>—  </a:t>
+              <a:t>•  </a:t>
             </a:r>
             <a:r>
               <a:rPr sz="1550">
@@ -11663,7 +11663,7 @@
                 </a:solidFill>
                 <a:latin typeface="Helvetica Neue"/>
               </a:rPr>
-              <a:t>—  </a:t>
+              <a:t>•  </a:t>
             </a:r>
             <a:r>
               <a:rPr sz="1550">
@@ -11691,7 +11691,7 @@
                 </a:solidFill>
                 <a:latin typeface="Helvetica Neue"/>
               </a:rPr>
-              <a:t>—  </a:t>
+              <a:t>•  </a:t>
             </a:r>
             <a:r>
               <a:rPr sz="1550">
@@ -11700,7 +11700,7 @@
                 </a:solidFill>
                 <a:latin typeface="Helvetica Neue"/>
               </a:rPr>
-              <a:t>This is the core of how commission gets generated — outreach is part of the job, not an optional extra.</a:t>
+              <a:t>This is the core of how commission gets generated: outreach is part of the job, not an optional extra.</a:t>
             </a:r>
           </a:p>
         </p:txBody>
@@ -12015,7 +12015,7 @@
                 </a:solidFill>
                 <a:latin typeface="Helvetica Neue"/>
               </a:rPr>
-              <a:t>Content focus is Zebraish Studio for now — Fashion content joins once the line launches.</a:t>
+              <a:t>Content focus is Zebraish Studio for now. Fashion content joins once the line launches.</a:t>
             </a:r>
           </a:p>
         </p:txBody>
@@ -13145,7 +13145,7 @@
                 </a:solidFill>
                 <a:latin typeface="Helvetica Neue"/>
               </a:rPr>
-              <a:t>Client introductions, commission, and the weekly payout — in plain terms.</a:t>
+              <a:t>Client introductions, commission, and the weekly payout, in plain terms.</a:t>
             </a:r>
           </a:p>
         </p:txBody>

</xml_diff>